<commit_message>
K-fold meme sur les chiffres montisse... pour mieux reconnaitre les diffrents nombre écrite
</commit_message>
<xml_diff>
--- a/rapport/Soutenance_IG2405_DeepForm.pptx
+++ b/rapport/Soutenance_IG2405_DeepForm.pptx
@@ -5854,7 +5854,7 @@
               </a:defRPr>
             </a:pPr>
             <a:r>
-              <a:t>62,7 % ± 4,2</a:t>
+              <a:t>66,0 % ± 3,5</a:t>
             </a:r>
           </a:p>
           <a:p>
@@ -5866,7 +5866,7 @@
               </a:defRPr>
             </a:pPr>
             <a:r>
-              <a:t>(folds : 69,9 / 60,4 / 64,7 / 60,4 / 58,0)</a:t>
+              <a:t>(folds : 70,5 / 62,2 / 68,0 / 67,4 / 61,6)</a:t>
             </a:r>
           </a:p>
           <a:p>
@@ -5920,7 +5920,19 @@
               </a:defRPr>
             </a:pPr>
             <a:r>
-              <a:t>Labels nettoyes : 59,5 -&gt; 62,7 % (+3,2).</a:t>
+              <a:t>59,5 -&gt; 62,7 (labels propres) -&gt; 66,0</a:t>
+            </a:r>
+          </a:p>
+          <a:p>
+            <a:pPr>
+              <a:defRPr sz="1300" b="1">
+                <a:solidFill>
+                  <a:srgbClr val="2E7D32"/>
+                </a:solidFill>
+              </a:defRPr>
+            </a:pPr>
+            <a:r>
+              <a:t>(lettres I/T entieres + cadrage).</a:t>
             </a:r>
           </a:p>
           <a:p>
@@ -6226,7 +6238,7 @@
               </a:defRPr>
             </a:pPr>
             <a:r>
-              <a:t>▪  Generalisation 3 formulaires : 66,2 % global — temps d'execution ~12 min (43 PDF + 32 photos, CPU)</a:t>
+              <a:t>▪  Generalisation 3 formulaires (130 PDFs) : 75,3 % global — imprime 94,7 / graphique 79,0 / signature 69,2 / manuscrit 35,9</a:t>
             </a:r>
           </a:p>
         </p:txBody>

</xml_diff>